<commit_message>
Validate ESRI shapefile components & UI updates
Add explicit validation for ESRI shapefile components and clarify UI/help text. Implement sae_validate_esri_shapefile_components() to require .shp, .shx and .dbf (and error with a helpful message listing missing parts), and call it from sae_read_geometry_input(). Update app UI and server messages to instruct users to upload a single .zip containing all shapefile components and adjust accepted geometry formats. Also include updated binary instruction/guidance documents (docx, pdf, pptx). This prevents missing .dbf/.shx issues that break mapping joins and makes user guidance consistent with the reader behavior.
</commit_message>
<xml_diff>
--- a/instructions/EU_SAE_User_Guide_Dashboard_v4.pptx
+++ b/instructions/EU_SAE_User_Guide_Dashboard_v4.pptx
@@ -12434,7 +12434,7 @@
                 <a:ea typeface="Calibri"/>
                 <a:cs typeface="Calibri"/>
               </a:rPr>
-              <a:t>Shapefile missing</a:t>
+              <a:t>Geometry file missing</a:t>
             </a:r>
           </a:p>
         </p:txBody>
@@ -12479,7 +12479,7 @@
                 <a:ea typeface="Consolas"/>
                 <a:cs typeface="Consolas"/>
               </a:rPr>
-              <a:t>choose .rds, .zip, .gpkg, or GeoJSON geometry</a:t>
+              <a:t>choose ESRI .zip (.shp/.shx/.dbf), .rds, .gpkg, or GeoJSON</a:t>
             </a:r>
           </a:p>
         </p:txBody>
@@ -30033,7 +30033,7 @@
                 <a:ea typeface="Calibri"/>
                 <a:cs typeface="Calibri"/>
               </a:rPr>
-              <a:t>Use Browse to select survey, auxiliary, and geometry files from any folder. Survey/auxiliary files can be .rds, .csv, .dta, or Excel; geometry can be .rds, .zip shapefile, .gpkg, or GeoJSON.</a:t>
+              <a:t>Use Browse to select survey, auxiliary, and geometry files from any folder. Survey/auxiliary files can be .rds, .csv, .dta, or Excel; geometry can be ESRI .zip (.shp/.shx/.dbf), .rds, .gpkg, or GeoJSON. Do not browse only the .shp file.</a:t>
             </a:r>
           </a:p>
         </p:txBody>
@@ -30797,7 +30797,7 @@
                 <a:ea typeface="Calibri"/>
                 <a:cs typeface="Calibri"/>
               </a:rPr>
-              <a:t>Check geometry domain IDs match your data and the mapped shapefile domain column.</a:t>
+              <a:t>Check geometry domain IDs match your data and the mapped geometry domain column. For ESRI shapefiles, use a .zip containing .shp, .shx, and .dbf.</a:t>
             </a:r>
           </a:p>
         </p:txBody>
@@ -36661,7 +36661,7 @@
                 <a:ea typeface="Calibri"/>
                 <a:cs typeface="Calibri"/>
               </a:rPr>
-              <a:t>Polygon boundaries for the target domains. Use .rds, zipped shapefile, .gpkg, or GeoJSON. Domain IDs must match the survey and auxiliary files.</a:t>
+              <a:t>Polygon boundaries for the target domains. Use ESRI .zip with .shp/.shx/.dbf, .rds, .gpkg, or GeoJSON. Domain IDs must match the survey and auxiliary files.</a:t>
             </a:r>
           </a:p>
         </p:txBody>

</xml_diff>